<commit_message>
docs: correct group to 21 and add presentation speech (PG-V2-006)
</commit_message>
<xml_diff>
--- a/docs/presentations/PrivacyGate_AI_Academic.pptx
+++ b/docs/presentations/PrivacyGate_AI_Academic.pptx
@@ -2,22 +2,22 @@
 <file path=ppt/presentation.xml><?xml version="1.0" encoding="utf-8"?>
 <p:presentation xmlns:p="http://schemas.openxmlformats.org/presentationml/2006/main">
   <p:sldMasterIdLst>
-    <p:sldMasterId xmlns:r="http://schemas.openxmlformats.org/officeDocument/2006/relationships" id="2147483648" r:id="Ra95fb716b3294b93"/>
+    <p:sldMasterId xmlns:r="http://schemas.openxmlformats.org/officeDocument/2006/relationships" id="2147483648" r:id="Rb8698c9765a14761"/>
   </p:sldMasterIdLst>
   <p:notesMasterIdLst>
-    <p:notesMasterId xmlns:r="http://schemas.openxmlformats.org/officeDocument/2006/relationships" r:id="Rb8fa184320944d3b"/>
+    <p:notesMasterId xmlns:r="http://schemas.openxmlformats.org/officeDocument/2006/relationships" r:id="R8bdcbe6aac2446b3"/>
   </p:notesMasterIdLst>
   <p:sldIdLst>
-    <p:sldId xmlns:r="http://schemas.openxmlformats.org/officeDocument/2006/relationships" id="256" r:id="R1ff326817c8b472a"/>
-    <p:sldId xmlns:r="http://schemas.openxmlformats.org/officeDocument/2006/relationships" id="257" r:id="R85cf4cf7cc504de1"/>
-    <p:sldId xmlns:r="http://schemas.openxmlformats.org/officeDocument/2006/relationships" id="258" r:id="Rb62cc0f7a2c54c36"/>
-    <p:sldId xmlns:r="http://schemas.openxmlformats.org/officeDocument/2006/relationships" id="259" r:id="Rb2c6b71d97a44ebb"/>
-    <p:sldId xmlns:r="http://schemas.openxmlformats.org/officeDocument/2006/relationships" id="260" r:id="R1fa21f2088b44acc"/>
-    <p:sldId xmlns:r="http://schemas.openxmlformats.org/officeDocument/2006/relationships" id="261" r:id="R6be6061ce4d245dd"/>
-    <p:sldId xmlns:r="http://schemas.openxmlformats.org/officeDocument/2006/relationships" id="262" r:id="R6b7d5d90077c4971"/>
-    <p:sldId xmlns:r="http://schemas.openxmlformats.org/officeDocument/2006/relationships" id="263" r:id="R323530df11914fd9"/>
-    <p:sldId xmlns:r="http://schemas.openxmlformats.org/officeDocument/2006/relationships" id="264" r:id="R8e06b7c5717c40f8"/>
-    <p:sldId xmlns:r="http://schemas.openxmlformats.org/officeDocument/2006/relationships" id="265" r:id="R5164ba36ed144c44"/>
+    <p:sldId xmlns:r="http://schemas.openxmlformats.org/officeDocument/2006/relationships" id="256" r:id="Rac5cd347e272463b"/>
+    <p:sldId xmlns:r="http://schemas.openxmlformats.org/officeDocument/2006/relationships" id="257" r:id="Rb7632f42d9e04b69"/>
+    <p:sldId xmlns:r="http://schemas.openxmlformats.org/officeDocument/2006/relationships" id="258" r:id="Rfe531fa21d8644c3"/>
+    <p:sldId xmlns:r="http://schemas.openxmlformats.org/officeDocument/2006/relationships" id="259" r:id="Rca318d8a58934959"/>
+    <p:sldId xmlns:r="http://schemas.openxmlformats.org/officeDocument/2006/relationships" id="260" r:id="Rf4714e1bc14a4b8a"/>
+    <p:sldId xmlns:r="http://schemas.openxmlformats.org/officeDocument/2006/relationships" id="261" r:id="R929c002847e54399"/>
+    <p:sldId xmlns:r="http://schemas.openxmlformats.org/officeDocument/2006/relationships" id="262" r:id="Rd3ae9591c273479c"/>
+    <p:sldId xmlns:r="http://schemas.openxmlformats.org/officeDocument/2006/relationships" id="263" r:id="Re1b2b0b529b94917"/>
+    <p:sldId xmlns:r="http://schemas.openxmlformats.org/officeDocument/2006/relationships" id="264" r:id="Rddbca4d6e34f400b"/>
+    <p:sldId xmlns:r="http://schemas.openxmlformats.org/officeDocument/2006/relationships" id="265" r:id="R80e33c9f8ed1469d"/>
   </p:sldIdLst>
   <p:sldSz cx="12192000" cy="6858000"/>
   <p:notesSz cx="6858000" cy="9144000"/>
@@ -451,7 +451,7 @@
           <a:lstStyle xmlns:a="http://schemas.openxmlformats.org/drawingml/2006/main"/>
           <a:p xmlns:a="http://schemas.openxmlformats.org/drawingml/2006/main">
             <a:r>
-              <a:t>Good morning. I am Sambhav Surana from Group 24. My project is PrivacyGate AI, a blockchain-based privacy-preserving IoT intelligence exchange. It demonstrates how an equipment owner can share a useful anomaly insight with an authorized reader while retaining detailed sensor readings locally. The current implementation is a Windows-native academic MVP with a local custom permission blockchain.</a:t>
+              <a:t>Good morning. I am Sambhav Surana from Group 21. My project is PrivacyGate AI, a blockchain-based privacy-preserving IoT intelligence exchange. It demonstrates how an equipment owner can share a useful anomaly insight with an authorized reader while retaining detailed sensor readings locally. The current implementation is a Windows-native academic MVP with a local custom permission blockchain.</a:t>
             </a:r>
           </a:p>
           <a:p xmlns:a="http://schemas.openxmlformats.org/drawingml/2006/main">
@@ -1278,7 +1278,7 @@
           <p:cNvPr id="3" name="Title">
             <a:extLst xmlns:a="http://schemas.openxmlformats.org/drawingml/2006/main">
               <a:ext uri="{FF2B5EF4-FFF2-40B4-BE49-F238E27FC236}">
-                <a16:creationId xmlns:a16="http://schemas.microsoft.com/office/drawing/2014/main" id="{3EC1EB52-6EB2-45E3-A5DA-30364FB24A80}"/>
+                <a16:creationId xmlns:a16="http://schemas.microsoft.com/office/drawing/2014/main" id="{5E5151A8-75DA-402F-9DA1-6BF99D19CB0A}"/>
               </a:ext>
             </a:extLst>
           </p:cNvPr>
@@ -1507,7 +1507,7 @@
           <p:cNvPr id="2" name="Subtitle">
             <a:extLst xmlns:a="http://schemas.openxmlformats.org/drawingml/2006/main">
               <a:ext uri="{FF2B5EF4-FFF2-40B4-BE49-F238E27FC236}">
-                <a16:creationId xmlns:a16="http://schemas.microsoft.com/office/drawing/2014/main" id="{5E71D014-3230-435A-BB7A-34AA4AFCE509}"/>
+                <a16:creationId xmlns:a16="http://schemas.microsoft.com/office/drawing/2014/main" id="{2A2CC416-D6E4-4297-B4B7-00D3B969507E}"/>
               </a:ext>
             </a:extLst>
           </p:cNvPr>
@@ -1753,7 +1753,7 @@
           <p:cNvPr id="2" name="Section title">
             <a:extLst xmlns:a="http://schemas.openxmlformats.org/drawingml/2006/main">
               <a:ext uri="{FF2B5EF4-FFF2-40B4-BE49-F238E27FC236}">
-                <a16:creationId xmlns:a16="http://schemas.microsoft.com/office/drawing/2014/main" id="{D4304F4D-01D6-47CC-928D-80AE460810DB}"/>
+                <a16:creationId xmlns:a16="http://schemas.microsoft.com/office/drawing/2014/main" id="{EE962BC2-1F98-42C1-AF6E-B4C93938AEDB}"/>
               </a:ext>
             </a:extLst>
           </p:cNvPr>
@@ -1999,7 +1999,7 @@
           <p:cNvPr id="3" name="Title">
             <a:extLst xmlns:a="http://schemas.openxmlformats.org/drawingml/2006/main">
               <a:ext uri="{FF2B5EF4-FFF2-40B4-BE49-F238E27FC236}">
-                <a16:creationId xmlns:a16="http://schemas.microsoft.com/office/drawing/2014/main" id="{42715A66-F09D-498C-A974-B64EDED42ED7}"/>
+                <a16:creationId xmlns:a16="http://schemas.microsoft.com/office/drawing/2014/main" id="{889ED17A-6706-4063-9BDB-301FE79C032C}"/>
               </a:ext>
             </a:extLst>
           </p:cNvPr>
@@ -2228,7 +2228,7 @@
           <p:cNvPr id="2" name="Body">
             <a:extLst xmlns:a="http://schemas.openxmlformats.org/drawingml/2006/main">
               <a:ext uri="{FF2B5EF4-FFF2-40B4-BE49-F238E27FC236}">
-                <a16:creationId xmlns:a16="http://schemas.microsoft.com/office/drawing/2014/main" id="{4AEB7EAD-1F4E-4BE8-B42D-1D2ACB26C7EA}"/>
+                <a16:creationId xmlns:a16="http://schemas.microsoft.com/office/drawing/2014/main" id="{6699A958-2C28-429D-95B4-06EBAE6E27A2}"/>
               </a:ext>
             </a:extLst>
           </p:cNvPr>
@@ -2474,7 +2474,7 @@
           <p:cNvPr id="4" name="Title">
             <a:extLst xmlns:a="http://schemas.openxmlformats.org/drawingml/2006/main">
               <a:ext uri="{FF2B5EF4-FFF2-40B4-BE49-F238E27FC236}">
-                <a16:creationId xmlns:a16="http://schemas.microsoft.com/office/drawing/2014/main" id="{B56721FC-1F8D-474E-89A8-F9EF95B95552}"/>
+                <a16:creationId xmlns:a16="http://schemas.microsoft.com/office/drawing/2014/main" id="{0E5DBFC9-2F8C-431A-8E63-9B5E3705CD6C}"/>
               </a:ext>
             </a:extLst>
           </p:cNvPr>
@@ -2703,7 +2703,7 @@
           <p:cNvPr id="2" name="Left column">
             <a:extLst xmlns:a="http://schemas.openxmlformats.org/drawingml/2006/main">
               <a:ext uri="{FF2B5EF4-FFF2-40B4-BE49-F238E27FC236}">
-                <a16:creationId xmlns:a16="http://schemas.microsoft.com/office/drawing/2014/main" id="{7EF0E1F7-742E-4D84-A543-1AA4E91C220C}"/>
+                <a16:creationId xmlns:a16="http://schemas.microsoft.com/office/drawing/2014/main" id="{857A6CE4-6865-4D77-8CB9-3DC07820ECCC}"/>
               </a:ext>
             </a:extLst>
           </p:cNvPr>
@@ -2932,7 +2932,7 @@
           <p:cNvPr id="3" name="Right column">
             <a:extLst xmlns:a="http://schemas.openxmlformats.org/drawingml/2006/main">
               <a:ext uri="{FF2B5EF4-FFF2-40B4-BE49-F238E27FC236}">
-                <a16:creationId xmlns:a16="http://schemas.microsoft.com/office/drawing/2014/main" id="{3EB6B554-4429-407A-B9C2-D5323CC344C3}"/>
+                <a16:creationId xmlns:a16="http://schemas.microsoft.com/office/drawing/2014/main" id="{087A6504-AEC7-4A77-AF27-43A98CFE2102}"/>
               </a:ext>
             </a:extLst>
           </p:cNvPr>
@@ -3178,7 +3178,7 @@
           <p:cNvPr id="3" name="Title">
             <a:extLst xmlns:a="http://schemas.openxmlformats.org/drawingml/2006/main">
               <a:ext uri="{FF2B5EF4-FFF2-40B4-BE49-F238E27FC236}">
-                <a16:creationId xmlns:a16="http://schemas.microsoft.com/office/drawing/2014/main" id="{15AD6C7D-CD8E-48DA-B0DF-0FEC9059B8F4}"/>
+                <a16:creationId xmlns:a16="http://schemas.microsoft.com/office/drawing/2014/main" id="{75DEEF74-52F2-4670-9DF3-C24B70942F7B}"/>
               </a:ext>
             </a:extLst>
           </p:cNvPr>
@@ -3407,7 +3407,7 @@
           <p:cNvPr id="2" name="Left column">
             <a:extLst xmlns:a="http://schemas.openxmlformats.org/drawingml/2006/main">
               <a:ext uri="{FF2B5EF4-FFF2-40B4-BE49-F238E27FC236}">
-                <a16:creationId xmlns:a16="http://schemas.microsoft.com/office/drawing/2014/main" id="{38902C0B-079F-4C40-AD8F-5F1A16E13C7E}"/>
+                <a16:creationId xmlns:a16="http://schemas.microsoft.com/office/drawing/2014/main" id="{93622FFF-4127-4266-9BE4-EB858BE706DB}"/>
               </a:ext>
             </a:extLst>
           </p:cNvPr>
@@ -3674,12 +3674,12 @@
   </p:cSld>
   <p:clrMap bg1="lt1" tx1="dk1" bg2="lt2" tx2="dk2" accent1="accent1" accent2="accent2" accent3="accent3" accent4="accent4" accent5="accent5" accent6="accent6" hlink="hlink" folHlink="folHlink"/>
   <p:sldLayoutIdLst>
-    <p:sldLayoutId xmlns:r="http://schemas.openxmlformats.org/officeDocument/2006/relationships" id="2147483649" r:id="R8533924c1d5d4b41"/>
-    <p:sldLayoutId xmlns:r="http://schemas.openxmlformats.org/officeDocument/2006/relationships" id="2147483650" r:id="R0b7156f3938d45a5"/>
-    <p:sldLayoutId xmlns:r="http://schemas.openxmlformats.org/officeDocument/2006/relationships" id="2147483651" r:id="Rd19f4c888f074edf"/>
-    <p:sldLayoutId xmlns:r="http://schemas.openxmlformats.org/officeDocument/2006/relationships" id="2147483652" r:id="Ra1e5ae7cc3514e98"/>
-    <p:sldLayoutId xmlns:r="http://schemas.openxmlformats.org/officeDocument/2006/relationships" id="2147483653" r:id="Raf7316d4c9514ffd"/>
-    <p:sldLayoutId xmlns:r="http://schemas.openxmlformats.org/officeDocument/2006/relationships" id="2147483654" r:id="R5fba5557716c4e79"/>
+    <p:sldLayoutId xmlns:r="http://schemas.openxmlformats.org/officeDocument/2006/relationships" id="2147483649" r:id="R863f190cf31d4c60"/>
+    <p:sldLayoutId xmlns:r="http://schemas.openxmlformats.org/officeDocument/2006/relationships" id="2147483650" r:id="R1170134c3dbe4651"/>
+    <p:sldLayoutId xmlns:r="http://schemas.openxmlformats.org/officeDocument/2006/relationships" id="2147483651" r:id="R0e2c3c6e6bc249ad"/>
+    <p:sldLayoutId xmlns:r="http://schemas.openxmlformats.org/officeDocument/2006/relationships" id="2147483652" r:id="R26affd41604f47e1"/>
+    <p:sldLayoutId xmlns:r="http://schemas.openxmlformats.org/officeDocument/2006/relationships" id="2147483653" r:id="R633f47828cb742ab"/>
+    <p:sldLayoutId xmlns:r="http://schemas.openxmlformats.org/officeDocument/2006/relationships" id="2147483654" r:id="Rd88ef51290a040c8"/>
   </p:sldLayoutIdLst>
   <p:txStyles>
     <p:titleStyle>
@@ -4230,7 +4230,7 @@
           <p:cNvPr id="8" name="">
             <a:extLst xmlns:a="http://schemas.openxmlformats.org/drawingml/2006/main">
               <a:ext uri="{FF2B5EF4-FFF2-40B4-BE49-F238E27FC236}">
-                <a16:creationId xmlns:a16="http://schemas.microsoft.com/office/drawing/2014/main" id="{CCF0DCB2-CD0E-4F5F-82F4-82087D3D93AF}"/>
+                <a16:creationId xmlns:a16="http://schemas.microsoft.com/office/drawing/2014/main" id="{44C097BD-D71E-4660-A224-E346C6B77E80}"/>
               </a:ext>
             </a:extLst>
           </p:cNvPr>
@@ -4386,7 +4386,7 @@
           <p:cNvPr id="2" name="">
             <a:extLst xmlns:a="http://schemas.openxmlformats.org/drawingml/2006/main">
               <a:ext uri="{FF2B5EF4-FFF2-40B4-BE49-F238E27FC236}">
-                <a16:creationId xmlns:a16="http://schemas.microsoft.com/office/drawing/2014/main" id="{A937A4AF-188C-441D-96BE-C65CA913232B}"/>
+                <a16:creationId xmlns:a16="http://schemas.microsoft.com/office/drawing/2014/main" id="{2AEB05EE-922C-4808-B6FC-C652023499B8}"/>
               </a:ext>
             </a:extLst>
           </p:cNvPr>
@@ -4542,7 +4542,7 @@
           <p:cNvPr id="3" name="">
             <a:extLst xmlns:a="http://schemas.openxmlformats.org/drawingml/2006/main">
               <a:ext uri="{FF2B5EF4-FFF2-40B4-BE49-F238E27FC236}">
-                <a16:creationId xmlns:a16="http://schemas.microsoft.com/office/drawing/2014/main" id="{074999F7-EA76-4B01-85FD-802CB021F2CF}"/>
+                <a16:creationId xmlns:a16="http://schemas.microsoft.com/office/drawing/2014/main" id="{E6C13BEF-A72D-4D24-B4BF-D514D3971743}"/>
               </a:ext>
             </a:extLst>
           </p:cNvPr>
@@ -4698,7 +4698,7 @@
           <p:cNvPr id="4" name="">
             <a:extLst xmlns:a="http://schemas.openxmlformats.org/drawingml/2006/main">
               <a:ext uri="{FF2B5EF4-FFF2-40B4-BE49-F238E27FC236}">
-                <a16:creationId xmlns:a16="http://schemas.microsoft.com/office/drawing/2014/main" id="{C0B40830-13D9-427D-8024-3A6ABFA32B39}"/>
+                <a16:creationId xmlns:a16="http://schemas.microsoft.com/office/drawing/2014/main" id="{DFAE94B7-A632-489B-B722-1374904025A6}"/>
               </a:ext>
             </a:extLst>
           </p:cNvPr>
@@ -4877,7 +4877,7 @@
           <p:cNvPr id="5" name="">
             <a:extLst xmlns:a="http://schemas.openxmlformats.org/drawingml/2006/main">
               <a:ext uri="{FF2B5EF4-FFF2-40B4-BE49-F238E27FC236}">
-                <a16:creationId xmlns:a16="http://schemas.microsoft.com/office/drawing/2014/main" id="{5A6EF595-FDB7-40DD-8AFF-5138E048E67E}"/>
+                <a16:creationId xmlns:a16="http://schemas.microsoft.com/office/drawing/2014/main" id="{24F3E760-10F3-4896-85F5-8F758296C9E3}"/>
               </a:ext>
             </a:extLst>
           </p:cNvPr>
@@ -5033,7 +5033,7 @@
           <p:cNvPr id="6" name="">
             <a:extLst xmlns:a="http://schemas.openxmlformats.org/drawingml/2006/main">
               <a:ext uri="{FF2B5EF4-FFF2-40B4-BE49-F238E27FC236}">
-                <a16:creationId xmlns:a16="http://schemas.microsoft.com/office/drawing/2014/main" id="{3E3A36DA-E5A8-4460-9A82-27D0A0F56022}"/>
+                <a16:creationId xmlns:a16="http://schemas.microsoft.com/office/drawing/2014/main" id="{E4E72CCA-97B5-46AF-95E8-37233880CBE8}"/>
               </a:ext>
             </a:extLst>
           </p:cNvPr>
@@ -5248,7 +5248,7 @@
                 <a:ea typeface="Arial"/>
                 <a:cs typeface="Arial"/>
               </a:rPr>
-              <a:t>Group 24</a:t>
+              <a:t>Group 21</a:t>
             </a:r>
           </a:p>
         </p:txBody>
@@ -5258,7 +5258,7 @@
           <p:cNvPr id="7" name="">
             <a:extLst xmlns:a="http://schemas.openxmlformats.org/drawingml/2006/main">
               <a:ext uri="{FF2B5EF4-FFF2-40B4-BE49-F238E27FC236}">
-                <a16:creationId xmlns:a16="http://schemas.microsoft.com/office/drawing/2014/main" id="{44C98551-0D88-4C13-B2EE-1F3FF47F2686}"/>
+                <a16:creationId xmlns:a16="http://schemas.microsoft.com/office/drawing/2014/main" id="{4F40FB40-575A-4EFD-9F75-4E0464B8631E}"/>
               </a:ext>
             </a:extLst>
           </p:cNvPr>
@@ -5463,7 +5463,7 @@
     </p:spTree>
     <p:extLst>
       <p:ext uri="{BB962C8B-B14F-4D97-AF65-F5344CB8AC3E}">
-        <p14:creationId xmlns:p14="http://schemas.microsoft.com/office/powerpoint/2010/main" val="2018290701"/>
+        <p14:creationId xmlns:p14="http://schemas.microsoft.com/office/powerpoint/2010/main" val="1258401086"/>
       </p:ext>
     </p:extLst>
   </p:cSld>
@@ -5494,7 +5494,7 @@
           <p:cNvPr id="11" name="">
             <a:extLst xmlns:a="http://schemas.openxmlformats.org/drawingml/2006/main">
               <a:ext uri="{FF2B5EF4-FFF2-40B4-BE49-F238E27FC236}">
-                <a16:creationId xmlns:a16="http://schemas.microsoft.com/office/drawing/2014/main" id="{E00BFE82-7D86-4859-8FB8-72CB55E1CE5C}"/>
+                <a16:creationId xmlns:a16="http://schemas.microsoft.com/office/drawing/2014/main" id="{1EECC94C-AC9B-45A5-9A1F-E308C7156F85}"/>
               </a:ext>
             </a:extLst>
           </p:cNvPr>
@@ -5650,7 +5650,7 @@
           <p:cNvPr id="2" name="">
             <a:extLst xmlns:a="http://schemas.openxmlformats.org/drawingml/2006/main">
               <a:ext uri="{FF2B5EF4-FFF2-40B4-BE49-F238E27FC236}">
-                <a16:creationId xmlns:a16="http://schemas.microsoft.com/office/drawing/2014/main" id="{E2AE3E69-EBFB-4CE4-921B-C7047589F85E}"/>
+                <a16:creationId xmlns:a16="http://schemas.microsoft.com/office/drawing/2014/main" id="{390980FC-7E0D-42A3-9360-6A5C241D5A27}"/>
               </a:ext>
             </a:extLst>
           </p:cNvPr>
@@ -5806,7 +5806,7 @@
           <p:cNvPr id="3" name="">
             <a:extLst xmlns:a="http://schemas.openxmlformats.org/drawingml/2006/main">
               <a:ext uri="{FF2B5EF4-FFF2-40B4-BE49-F238E27FC236}">
-                <a16:creationId xmlns:a16="http://schemas.microsoft.com/office/drawing/2014/main" id="{0618E7F6-C124-4E42-91CC-D374E572AD5C}"/>
+                <a16:creationId xmlns:a16="http://schemas.microsoft.com/office/drawing/2014/main" id="{1CFEBD38-5481-45AD-87F3-AF2085A0CDE2}"/>
               </a:ext>
             </a:extLst>
           </p:cNvPr>
@@ -5962,7 +5962,7 @@
           <p:cNvPr id="4" name="">
             <a:extLst xmlns:a="http://schemas.openxmlformats.org/drawingml/2006/main">
               <a:ext uri="{FF2B5EF4-FFF2-40B4-BE49-F238E27FC236}">
-                <a16:creationId xmlns:a16="http://schemas.microsoft.com/office/drawing/2014/main" id="{E6CD846F-4607-4BF8-8E74-5182A79BABF0}"/>
+                <a16:creationId xmlns:a16="http://schemas.microsoft.com/office/drawing/2014/main" id="{116A3D6B-A002-4286-8FD1-CA771B048563}"/>
               </a:ext>
             </a:extLst>
           </p:cNvPr>
@@ -6118,7 +6118,7 @@
           <p:cNvPr id="5" name="">
             <a:extLst xmlns:a="http://schemas.openxmlformats.org/drawingml/2006/main">
               <a:ext uri="{FF2B5EF4-FFF2-40B4-BE49-F238E27FC236}">
-                <a16:creationId xmlns:a16="http://schemas.microsoft.com/office/drawing/2014/main" id="{447A7816-55F9-438D-B2F5-02B805707102}"/>
+                <a16:creationId xmlns:a16="http://schemas.microsoft.com/office/drawing/2014/main" id="{75151946-1238-47B7-9B36-DB6B64AA6777}"/>
               </a:ext>
             </a:extLst>
           </p:cNvPr>
@@ -6297,7 +6297,7 @@
           <p:cNvPr id="6" name="">
             <a:extLst xmlns:a="http://schemas.openxmlformats.org/drawingml/2006/main">
               <a:ext uri="{FF2B5EF4-FFF2-40B4-BE49-F238E27FC236}">
-                <a16:creationId xmlns:a16="http://schemas.microsoft.com/office/drawing/2014/main" id="{5D47ECF5-C2E1-4F84-A272-D668CCE20387}"/>
+                <a16:creationId xmlns:a16="http://schemas.microsoft.com/office/drawing/2014/main" id="{B7EFE21C-4F69-4235-BEFA-8895FE308BE3}"/>
               </a:ext>
             </a:extLst>
           </p:cNvPr>
@@ -6453,7 +6453,7 @@
           <p:cNvPr id="7" name="">
             <a:extLst xmlns:a="http://schemas.openxmlformats.org/drawingml/2006/main">
               <a:ext uri="{FF2B5EF4-FFF2-40B4-BE49-F238E27FC236}">
-                <a16:creationId xmlns:a16="http://schemas.microsoft.com/office/drawing/2014/main" id="{11F922B2-C34C-43CA-A891-AD28A2843F87}"/>
+                <a16:creationId xmlns:a16="http://schemas.microsoft.com/office/drawing/2014/main" id="{B8093077-B51B-40CD-8637-02641DBC6F82}"/>
               </a:ext>
             </a:extLst>
           </p:cNvPr>
@@ -6609,7 +6609,7 @@
           <p:cNvPr id="8" name="">
             <a:extLst xmlns:a="http://schemas.openxmlformats.org/drawingml/2006/main">
               <a:ext uri="{FF2B5EF4-FFF2-40B4-BE49-F238E27FC236}">
-                <a16:creationId xmlns:a16="http://schemas.microsoft.com/office/drawing/2014/main" id="{BAE41BF2-FEE9-429A-8830-4882B52D0AA6}"/>
+                <a16:creationId xmlns:a16="http://schemas.microsoft.com/office/drawing/2014/main" id="{5731C5E6-9719-42E6-B18C-C68973B4D9E6}"/>
               </a:ext>
             </a:extLst>
           </p:cNvPr>
@@ -6811,7 +6811,7 @@
           <p:cNvPr id="9" name="">
             <a:extLst xmlns:a="http://schemas.openxmlformats.org/drawingml/2006/main">
               <a:ext uri="{FF2B5EF4-FFF2-40B4-BE49-F238E27FC236}">
-                <a16:creationId xmlns:a16="http://schemas.microsoft.com/office/drawing/2014/main" id="{D5EA2417-CFEA-4432-8398-346DD5B518CB}"/>
+                <a16:creationId xmlns:a16="http://schemas.microsoft.com/office/drawing/2014/main" id="{3CA792E4-6D3C-408D-8043-7351A1622049}"/>
               </a:ext>
             </a:extLst>
           </p:cNvPr>
@@ -7013,7 +7013,7 @@
           <p:cNvPr id="10" name="">
             <a:extLst xmlns:a="http://schemas.openxmlformats.org/drawingml/2006/main">
               <a:ext uri="{FF2B5EF4-FFF2-40B4-BE49-F238E27FC236}">
-                <a16:creationId xmlns:a16="http://schemas.microsoft.com/office/drawing/2014/main" id="{38FA406F-EB52-4D2B-917D-A440911FAA0C}"/>
+                <a16:creationId xmlns:a16="http://schemas.microsoft.com/office/drawing/2014/main" id="{B9C96197-2206-4BB4-B029-75535A448993}"/>
               </a:ext>
             </a:extLst>
           </p:cNvPr>
@@ -7167,7 +7167,7 @@
     </p:spTree>
     <p:extLst>
       <p:ext uri="{BB962C8B-B14F-4D97-AF65-F5344CB8AC3E}">
-        <p14:creationId xmlns:p14="http://schemas.microsoft.com/office/powerpoint/2010/main" val="1985841513"/>
+        <p14:creationId xmlns:p14="http://schemas.microsoft.com/office/powerpoint/2010/main" val="657900009"/>
       </p:ext>
     </p:extLst>
   </p:cSld>
@@ -7198,7 +7198,7 @@
           <p:cNvPr id="10" name="">
             <a:extLst xmlns:a="http://schemas.openxmlformats.org/drawingml/2006/main">
               <a:ext uri="{FF2B5EF4-FFF2-40B4-BE49-F238E27FC236}">
-                <a16:creationId xmlns:a16="http://schemas.microsoft.com/office/drawing/2014/main" id="{05BD5427-F96F-462C-9FC9-8DF481A96C73}"/>
+                <a16:creationId xmlns:a16="http://schemas.microsoft.com/office/drawing/2014/main" id="{539C09E6-A65F-49C2-807C-9E826C30C61B}"/>
               </a:ext>
             </a:extLst>
           </p:cNvPr>
@@ -7354,7 +7354,7 @@
           <p:cNvPr id="2" name="">
             <a:extLst xmlns:a="http://schemas.openxmlformats.org/drawingml/2006/main">
               <a:ext uri="{FF2B5EF4-FFF2-40B4-BE49-F238E27FC236}">
-                <a16:creationId xmlns:a16="http://schemas.microsoft.com/office/drawing/2014/main" id="{78F7972E-AE32-48E2-BD74-156C294A255C}"/>
+                <a16:creationId xmlns:a16="http://schemas.microsoft.com/office/drawing/2014/main" id="{351B712A-7A1E-45A4-B015-4DB77D2D8F3D}"/>
               </a:ext>
             </a:extLst>
           </p:cNvPr>
@@ -7510,7 +7510,7 @@
           <p:cNvPr id="3" name="">
             <a:extLst xmlns:a="http://schemas.openxmlformats.org/drawingml/2006/main">
               <a:ext uri="{FF2B5EF4-FFF2-40B4-BE49-F238E27FC236}">
-                <a16:creationId xmlns:a16="http://schemas.microsoft.com/office/drawing/2014/main" id="{E8E94F2F-1766-4783-A916-6D6E267FD635}"/>
+                <a16:creationId xmlns:a16="http://schemas.microsoft.com/office/drawing/2014/main" id="{71C02D4F-BBC1-452E-9B9E-94BA8ECBBED8}"/>
               </a:ext>
             </a:extLst>
           </p:cNvPr>
@@ -7666,7 +7666,7 @@
           <p:cNvPr id="4" name="">
             <a:extLst xmlns:a="http://schemas.openxmlformats.org/drawingml/2006/main">
               <a:ext uri="{FF2B5EF4-FFF2-40B4-BE49-F238E27FC236}">
-                <a16:creationId xmlns:a16="http://schemas.microsoft.com/office/drawing/2014/main" id="{AB216B1D-749B-42EC-AF3B-0DB37AED1411}"/>
+                <a16:creationId xmlns:a16="http://schemas.microsoft.com/office/drawing/2014/main" id="{D1340198-E3B5-4D90-9C93-8D0C2C791CA1}"/>
               </a:ext>
             </a:extLst>
           </p:cNvPr>
@@ -7822,7 +7822,7 @@
           <p:cNvPr id="5" name="">
             <a:extLst xmlns:a="http://schemas.openxmlformats.org/drawingml/2006/main">
               <a:ext uri="{FF2B5EF4-FFF2-40B4-BE49-F238E27FC236}">
-                <a16:creationId xmlns:a16="http://schemas.microsoft.com/office/drawing/2014/main" id="{AB17B1C7-A421-46FC-9470-CE3A0829139F}"/>
+                <a16:creationId xmlns:a16="http://schemas.microsoft.com/office/drawing/2014/main" id="{AF18BE93-5CE6-4960-946D-03BEBAB5BEFB}"/>
               </a:ext>
             </a:extLst>
           </p:cNvPr>
@@ -7978,7 +7978,7 @@
           <p:cNvPr id="6" name="">
             <a:extLst xmlns:a="http://schemas.openxmlformats.org/drawingml/2006/main">
               <a:ext uri="{FF2B5EF4-FFF2-40B4-BE49-F238E27FC236}">
-                <a16:creationId xmlns:a16="http://schemas.microsoft.com/office/drawing/2014/main" id="{F1FDC28B-9A45-4319-97F3-FD27D2FD9DEE}"/>
+                <a16:creationId xmlns:a16="http://schemas.microsoft.com/office/drawing/2014/main" id="{92820306-6B61-4803-BB9F-1FE707FA96ED}"/>
               </a:ext>
             </a:extLst>
           </p:cNvPr>
@@ -8134,7 +8134,7 @@
           <p:cNvPr id="7" name="">
             <a:extLst xmlns:a="http://schemas.openxmlformats.org/drawingml/2006/main">
               <a:ext uri="{FF2B5EF4-FFF2-40B4-BE49-F238E27FC236}">
-                <a16:creationId xmlns:a16="http://schemas.microsoft.com/office/drawing/2014/main" id="{52987510-0F0E-4A71-9C5F-2F4AC7987533}"/>
+                <a16:creationId xmlns:a16="http://schemas.microsoft.com/office/drawing/2014/main" id="{2A9D6FB3-E06C-4315-816A-EF70C97CD440}"/>
               </a:ext>
             </a:extLst>
           </p:cNvPr>
@@ -8290,7 +8290,7 @@
           <p:cNvPr id="8" name="">
             <a:extLst xmlns:a="http://schemas.openxmlformats.org/drawingml/2006/main">
               <a:ext uri="{FF2B5EF4-FFF2-40B4-BE49-F238E27FC236}">
-                <a16:creationId xmlns:a16="http://schemas.microsoft.com/office/drawing/2014/main" id="{A10BB1B9-3C44-4FD9-88D3-488C7FB21AFF}"/>
+                <a16:creationId xmlns:a16="http://schemas.microsoft.com/office/drawing/2014/main" id="{86BA6C20-D3BB-4752-B905-9E762F4CEE3D}"/>
               </a:ext>
             </a:extLst>
           </p:cNvPr>
@@ -8446,7 +8446,7 @@
           <p:cNvPr id="9" name="">
             <a:extLst xmlns:a="http://schemas.openxmlformats.org/drawingml/2006/main">
               <a:ext uri="{FF2B5EF4-FFF2-40B4-BE49-F238E27FC236}">
-                <a16:creationId xmlns:a16="http://schemas.microsoft.com/office/drawing/2014/main" id="{F2FF29BF-F3F6-451D-BD7C-8AB70E03E4FB}"/>
+                <a16:creationId xmlns:a16="http://schemas.microsoft.com/office/drawing/2014/main" id="{8E512A8D-DB88-4A08-99F5-EECFF6FC28F1}"/>
               </a:ext>
             </a:extLst>
           </p:cNvPr>
@@ -8600,7 +8600,7 @@
     </p:spTree>
     <p:extLst>
       <p:ext uri="{BB962C8B-B14F-4D97-AF65-F5344CB8AC3E}">
-        <p14:creationId xmlns:p14="http://schemas.microsoft.com/office/powerpoint/2010/main" val="1633140069"/>
+        <p14:creationId xmlns:p14="http://schemas.microsoft.com/office/powerpoint/2010/main" val="732798160"/>
       </p:ext>
     </p:extLst>
   </p:cSld>
@@ -8631,7 +8631,7 @@
           <p:cNvPr id="12" name="">
             <a:extLst xmlns:a="http://schemas.openxmlformats.org/drawingml/2006/main">
               <a:ext uri="{FF2B5EF4-FFF2-40B4-BE49-F238E27FC236}">
-                <a16:creationId xmlns:a16="http://schemas.microsoft.com/office/drawing/2014/main" id="{EBAE408F-CFBC-43B2-A066-20F41252E8F8}"/>
+                <a16:creationId xmlns:a16="http://schemas.microsoft.com/office/drawing/2014/main" id="{BE5A6684-6E4E-4F31-9B1D-9590A449FA54}"/>
               </a:ext>
             </a:extLst>
           </p:cNvPr>
@@ -8787,7 +8787,7 @@
           <p:cNvPr id="2" name="">
             <a:extLst xmlns:a="http://schemas.openxmlformats.org/drawingml/2006/main">
               <a:ext uri="{FF2B5EF4-FFF2-40B4-BE49-F238E27FC236}">
-                <a16:creationId xmlns:a16="http://schemas.microsoft.com/office/drawing/2014/main" id="{645C37AC-7FCC-4D57-A54F-AE6426EE4D9A}"/>
+                <a16:creationId xmlns:a16="http://schemas.microsoft.com/office/drawing/2014/main" id="{7EFE0958-2D13-4F45-8A5E-E179C9E22FC9}"/>
               </a:ext>
             </a:extLst>
           </p:cNvPr>
@@ -8943,7 +8943,7 @@
           <p:cNvPr id="3" name="">
             <a:extLst xmlns:a="http://schemas.openxmlformats.org/drawingml/2006/main">
               <a:ext uri="{FF2B5EF4-FFF2-40B4-BE49-F238E27FC236}">
-                <a16:creationId xmlns:a16="http://schemas.microsoft.com/office/drawing/2014/main" id="{A87BF09C-5B10-4A3A-8021-14731648528F}"/>
+                <a16:creationId xmlns:a16="http://schemas.microsoft.com/office/drawing/2014/main" id="{221B04C7-3A8C-438E-92ED-CF3F8F00A951}"/>
               </a:ext>
             </a:extLst>
           </p:cNvPr>
@@ -9099,7 +9099,7 @@
           <p:cNvPr id="4" name="">
             <a:extLst xmlns:a="http://schemas.openxmlformats.org/drawingml/2006/main">
               <a:ext uri="{FF2B5EF4-FFF2-40B4-BE49-F238E27FC236}">
-                <a16:creationId xmlns:a16="http://schemas.microsoft.com/office/drawing/2014/main" id="{0E924373-E167-4008-99EA-B08789232937}"/>
+                <a16:creationId xmlns:a16="http://schemas.microsoft.com/office/drawing/2014/main" id="{9F25C4BF-D56A-493E-8026-72A93815EC7F}"/>
               </a:ext>
             </a:extLst>
           </p:cNvPr>
@@ -9255,7 +9255,7 @@
           <p:cNvPr id="5" name="">
             <a:extLst xmlns:a="http://schemas.openxmlformats.org/drawingml/2006/main">
               <a:ext uri="{FF2B5EF4-FFF2-40B4-BE49-F238E27FC236}">
-                <a16:creationId xmlns:a16="http://schemas.microsoft.com/office/drawing/2014/main" id="{23662FC2-960C-4C15-A6CB-55B3556D08F0}"/>
+                <a16:creationId xmlns:a16="http://schemas.microsoft.com/office/drawing/2014/main" id="{D63A0340-EFDD-4172-9056-E6CF218D42BF}"/>
               </a:ext>
             </a:extLst>
           </p:cNvPr>
@@ -9411,7 +9411,7 @@
           <p:cNvPr id="6" name="">
             <a:extLst xmlns:a="http://schemas.openxmlformats.org/drawingml/2006/main">
               <a:ext uri="{FF2B5EF4-FFF2-40B4-BE49-F238E27FC236}">
-                <a16:creationId xmlns:a16="http://schemas.microsoft.com/office/drawing/2014/main" id="{A2A192DA-B7D2-428F-96DE-4167EE29BA3E}"/>
+                <a16:creationId xmlns:a16="http://schemas.microsoft.com/office/drawing/2014/main" id="{6C6FFA86-CF04-451F-9299-B906D10CAD63}"/>
               </a:ext>
             </a:extLst>
           </p:cNvPr>
@@ -9567,7 +9567,7 @@
           <p:cNvPr id="7" name="">
             <a:extLst xmlns:a="http://schemas.openxmlformats.org/drawingml/2006/main">
               <a:ext uri="{FF2B5EF4-FFF2-40B4-BE49-F238E27FC236}">
-                <a16:creationId xmlns:a16="http://schemas.microsoft.com/office/drawing/2014/main" id="{CB107CB7-E949-4E53-B5F3-3D11CB1D4779}"/>
+                <a16:creationId xmlns:a16="http://schemas.microsoft.com/office/drawing/2014/main" id="{DC368286-2849-4FDF-9FD5-FB9DD73689CC}"/>
               </a:ext>
             </a:extLst>
           </p:cNvPr>
@@ -9723,7 +9723,7 @@
           <p:cNvPr id="8" name="">
             <a:extLst xmlns:a="http://schemas.openxmlformats.org/drawingml/2006/main">
               <a:ext uri="{FF2B5EF4-FFF2-40B4-BE49-F238E27FC236}">
-                <a16:creationId xmlns:a16="http://schemas.microsoft.com/office/drawing/2014/main" id="{763F65DF-3794-4742-B149-75FA21EB16C9}"/>
+                <a16:creationId xmlns:a16="http://schemas.microsoft.com/office/drawing/2014/main" id="{C112EAA8-0FF5-482B-BC29-62266F764763}"/>
               </a:ext>
             </a:extLst>
           </p:cNvPr>
@@ -9879,7 +9879,7 @@
           <p:cNvPr id="9" name="">
             <a:extLst xmlns:a="http://schemas.openxmlformats.org/drawingml/2006/main">
               <a:ext uri="{FF2B5EF4-FFF2-40B4-BE49-F238E27FC236}">
-                <a16:creationId xmlns:a16="http://schemas.microsoft.com/office/drawing/2014/main" id="{07FE75DB-D5FA-4405-99CB-3AECA49EB5DE}"/>
+                <a16:creationId xmlns:a16="http://schemas.microsoft.com/office/drawing/2014/main" id="{3B1F0758-E180-462B-B694-169EF3C2A82C}"/>
               </a:ext>
             </a:extLst>
           </p:cNvPr>
@@ -10035,7 +10035,7 @@
           <p:cNvPr id="10" name="">
             <a:extLst xmlns:a="http://schemas.openxmlformats.org/drawingml/2006/main">
               <a:ext uri="{FF2B5EF4-FFF2-40B4-BE49-F238E27FC236}">
-                <a16:creationId xmlns:a16="http://schemas.microsoft.com/office/drawing/2014/main" id="{12A61578-3F3C-490D-85A1-FE39B75CE788}"/>
+                <a16:creationId xmlns:a16="http://schemas.microsoft.com/office/drawing/2014/main" id="{2E3587E5-29D2-43EC-B85E-76DA1DCE75B8}"/>
               </a:ext>
             </a:extLst>
           </p:cNvPr>
@@ -10191,7 +10191,7 @@
           <p:cNvPr id="11" name="">
             <a:extLst xmlns:a="http://schemas.openxmlformats.org/drawingml/2006/main">
               <a:ext uri="{FF2B5EF4-FFF2-40B4-BE49-F238E27FC236}">
-                <a16:creationId xmlns:a16="http://schemas.microsoft.com/office/drawing/2014/main" id="{3073D602-CBE7-4C7A-8610-4F1D20A1E8D4}"/>
+                <a16:creationId xmlns:a16="http://schemas.microsoft.com/office/drawing/2014/main" id="{4FA4BCD3-5081-40AF-BAFE-C0BB863AE575}"/>
               </a:ext>
             </a:extLst>
           </p:cNvPr>
@@ -10345,7 +10345,7 @@
     </p:spTree>
     <p:extLst>
       <p:ext uri="{BB962C8B-B14F-4D97-AF65-F5344CB8AC3E}">
-        <p14:creationId xmlns:p14="http://schemas.microsoft.com/office/powerpoint/2010/main" val="1131161780"/>
+        <p14:creationId xmlns:p14="http://schemas.microsoft.com/office/powerpoint/2010/main" val="973019826"/>
       </p:ext>
     </p:extLst>
   </p:cSld>
@@ -10376,7 +10376,7 @@
           <p:cNvPr id="6" name="">
             <a:extLst xmlns:a="http://schemas.openxmlformats.org/drawingml/2006/main">
               <a:ext uri="{FF2B5EF4-FFF2-40B4-BE49-F238E27FC236}">
-                <a16:creationId xmlns:a16="http://schemas.microsoft.com/office/drawing/2014/main" id="{FAACBB58-6C9D-47AB-95BC-59F90227B428}"/>
+                <a16:creationId xmlns:a16="http://schemas.microsoft.com/office/drawing/2014/main" id="{71E1ECC7-142C-4BF2-BE72-728DC5BE5556}"/>
               </a:ext>
             </a:extLst>
           </p:cNvPr>
@@ -10532,7 +10532,7 @@
           <p:cNvPr id="2" name="">
             <a:extLst xmlns:a="http://schemas.openxmlformats.org/drawingml/2006/main">
               <a:ext uri="{FF2B5EF4-FFF2-40B4-BE49-F238E27FC236}">
-                <a16:creationId xmlns:a16="http://schemas.microsoft.com/office/drawing/2014/main" id="{DBD956A5-FFD2-4163-BFAC-217A40CA21D1}"/>
+                <a16:creationId xmlns:a16="http://schemas.microsoft.com/office/drawing/2014/main" id="{D7F10C9A-F994-4563-8697-228CA45B1B43}"/>
               </a:ext>
             </a:extLst>
           </p:cNvPr>
@@ -10688,7 +10688,7 @@
           <p:cNvPr id="3" name="">
             <a:extLst xmlns:a="http://schemas.openxmlformats.org/drawingml/2006/main">
               <a:ext uri="{FF2B5EF4-FFF2-40B4-BE49-F238E27FC236}">
-                <a16:creationId xmlns:a16="http://schemas.microsoft.com/office/drawing/2014/main" id="{6E656A8C-85CC-42B5-B0DA-CFE59712C426}"/>
+                <a16:creationId xmlns:a16="http://schemas.microsoft.com/office/drawing/2014/main" id="{89F052BC-1450-4834-97DF-133370E41B15}"/>
               </a:ext>
             </a:extLst>
           </p:cNvPr>
@@ -10844,7 +10844,7 @@
           <p:cNvPr id="4" name="">
             <a:extLst xmlns:a="http://schemas.openxmlformats.org/drawingml/2006/main">
               <a:ext uri="{FF2B5EF4-FFF2-40B4-BE49-F238E27FC236}">
-                <a16:creationId xmlns:a16="http://schemas.microsoft.com/office/drawing/2014/main" id="{9A322778-D5E3-4BF0-9C68-BBDE6ADAE957}"/>
+                <a16:creationId xmlns:a16="http://schemas.microsoft.com/office/drawing/2014/main" id="{7339BC91-19F5-4FA9-B8B5-CACA14E3F5E1}"/>
               </a:ext>
             </a:extLst>
           </p:cNvPr>
@@ -10854,7 +10854,7 @@
           <p:nvPr/>
         </p:nvPicPr>
         <p:blipFill>
-          <a:blip xmlns:r="http://schemas.openxmlformats.org/officeDocument/2006/relationships" xmlns:a="http://schemas.openxmlformats.org/drawingml/2006/main" r:embed="R2602bd8e07f24e2f"/>
+          <a:blip xmlns:r="http://schemas.openxmlformats.org/officeDocument/2006/relationships" xmlns:a="http://schemas.openxmlformats.org/drawingml/2006/main" r:embed="R923a7b23d93e4703"/>
           <a:stretch xmlns:a="http://schemas.openxmlformats.org/drawingml/2006/main"/>
         </p:blipFill>
         <p:spPr>
@@ -10872,7 +10872,7 @@
           <p:cNvPr id="5" name="">
             <a:extLst xmlns:a="http://schemas.openxmlformats.org/drawingml/2006/main">
               <a:ext uri="{FF2B5EF4-FFF2-40B4-BE49-F238E27FC236}">
-                <a16:creationId xmlns:a16="http://schemas.microsoft.com/office/drawing/2014/main" id="{DC6E82A8-5B4B-4075-B39D-077907B14DE9}"/>
+                <a16:creationId xmlns:a16="http://schemas.microsoft.com/office/drawing/2014/main" id="{8DBC9C76-5086-40E7-AAAD-B744BD594EC7}"/>
               </a:ext>
             </a:extLst>
           </p:cNvPr>
@@ -11026,7 +11026,7 @@
     </p:spTree>
     <p:extLst>
       <p:ext uri="{BB962C8B-B14F-4D97-AF65-F5344CB8AC3E}">
-        <p14:creationId xmlns:p14="http://schemas.microsoft.com/office/powerpoint/2010/main" val="2098854845"/>
+        <p14:creationId xmlns:p14="http://schemas.microsoft.com/office/powerpoint/2010/main" val="1628101861"/>
       </p:ext>
     </p:extLst>
   </p:cSld>
@@ -11057,7 +11057,7 @@
           <p:cNvPr id="12" name="">
             <a:extLst xmlns:a="http://schemas.openxmlformats.org/drawingml/2006/main">
               <a:ext uri="{FF2B5EF4-FFF2-40B4-BE49-F238E27FC236}">
-                <a16:creationId xmlns:a16="http://schemas.microsoft.com/office/drawing/2014/main" id="{F61FFB7D-491C-4BF7-BFC8-361488198C77}"/>
+                <a16:creationId xmlns:a16="http://schemas.microsoft.com/office/drawing/2014/main" id="{566C47C0-3451-4B94-AA66-DA6B35F49404}"/>
               </a:ext>
             </a:extLst>
           </p:cNvPr>
@@ -11213,7 +11213,7 @@
           <p:cNvPr id="2" name="">
             <a:extLst xmlns:a="http://schemas.openxmlformats.org/drawingml/2006/main">
               <a:ext uri="{FF2B5EF4-FFF2-40B4-BE49-F238E27FC236}">
-                <a16:creationId xmlns:a16="http://schemas.microsoft.com/office/drawing/2014/main" id="{4F64E846-F8B5-4E5A-81ED-2FF27B4341AC}"/>
+                <a16:creationId xmlns:a16="http://schemas.microsoft.com/office/drawing/2014/main" id="{C2D42304-03BC-4F72-AFCC-74BF097B3B61}"/>
               </a:ext>
             </a:extLst>
           </p:cNvPr>
@@ -11369,7 +11369,7 @@
           <p:cNvPr id="3" name="">
             <a:extLst xmlns:a="http://schemas.openxmlformats.org/drawingml/2006/main">
               <a:ext uri="{FF2B5EF4-FFF2-40B4-BE49-F238E27FC236}">
-                <a16:creationId xmlns:a16="http://schemas.microsoft.com/office/drawing/2014/main" id="{28C0AED1-39B0-40EF-B22E-D30A2730C786}"/>
+                <a16:creationId xmlns:a16="http://schemas.microsoft.com/office/drawing/2014/main" id="{D09C649E-6078-4FB6-B6EE-30AC4AF1F2D9}"/>
               </a:ext>
             </a:extLst>
           </p:cNvPr>
@@ -11525,7 +11525,7 @@
           <p:cNvPr id="4" name="">
             <a:extLst xmlns:a="http://schemas.openxmlformats.org/drawingml/2006/main">
               <a:ext uri="{FF2B5EF4-FFF2-40B4-BE49-F238E27FC236}">
-                <a16:creationId xmlns:a16="http://schemas.microsoft.com/office/drawing/2014/main" id="{08BBAF52-1CE2-4C59-B97F-373D63B81007}"/>
+                <a16:creationId xmlns:a16="http://schemas.microsoft.com/office/drawing/2014/main" id="{3685CB9C-8939-463A-BACA-4A18681C534A}"/>
               </a:ext>
             </a:extLst>
           </p:cNvPr>
@@ -11681,7 +11681,7 @@
           <p:cNvPr id="5" name="">
             <a:extLst xmlns:a="http://schemas.openxmlformats.org/drawingml/2006/main">
               <a:ext uri="{FF2B5EF4-FFF2-40B4-BE49-F238E27FC236}">
-                <a16:creationId xmlns:a16="http://schemas.microsoft.com/office/drawing/2014/main" id="{DE9AAFE5-82A8-433F-A04E-F4337075BD2F}"/>
+                <a16:creationId xmlns:a16="http://schemas.microsoft.com/office/drawing/2014/main" id="{2137591D-71C3-487E-88F0-56A731D0A9B5}"/>
               </a:ext>
             </a:extLst>
           </p:cNvPr>
@@ -11837,7 +11837,7 @@
           <p:cNvPr id="6" name="">
             <a:extLst xmlns:a="http://schemas.openxmlformats.org/drawingml/2006/main">
               <a:ext uri="{FF2B5EF4-FFF2-40B4-BE49-F238E27FC236}">
-                <a16:creationId xmlns:a16="http://schemas.microsoft.com/office/drawing/2014/main" id="{636A9E8C-66ED-4A83-93EC-7F44B6B5A6E5}"/>
+                <a16:creationId xmlns:a16="http://schemas.microsoft.com/office/drawing/2014/main" id="{7D316F96-2832-4D99-9F87-496688029541}"/>
               </a:ext>
             </a:extLst>
           </p:cNvPr>
@@ -11993,7 +11993,7 @@
           <p:cNvPr id="7" name="">
             <a:extLst xmlns:a="http://schemas.openxmlformats.org/drawingml/2006/main">
               <a:ext uri="{FF2B5EF4-FFF2-40B4-BE49-F238E27FC236}">
-                <a16:creationId xmlns:a16="http://schemas.microsoft.com/office/drawing/2014/main" id="{2300AF58-6732-4C30-8CEF-E255B05D76D2}"/>
+                <a16:creationId xmlns:a16="http://schemas.microsoft.com/office/drawing/2014/main" id="{1E8E7534-3508-4064-A2AD-CCB540F2C77B}"/>
               </a:ext>
             </a:extLst>
           </p:cNvPr>
@@ -12149,7 +12149,7 @@
           <p:cNvPr id="8" name="">
             <a:extLst xmlns:a="http://schemas.openxmlformats.org/drawingml/2006/main">
               <a:ext uri="{FF2B5EF4-FFF2-40B4-BE49-F238E27FC236}">
-                <a16:creationId xmlns:a16="http://schemas.microsoft.com/office/drawing/2014/main" id="{BAE93BF0-9AE3-4335-A364-5B60D18914CE}"/>
+                <a16:creationId xmlns:a16="http://schemas.microsoft.com/office/drawing/2014/main" id="{13960A31-CE3C-479B-9E86-C333448D3D83}"/>
               </a:ext>
             </a:extLst>
           </p:cNvPr>
@@ -12305,7 +12305,7 @@
           <p:cNvPr id="9" name="">
             <a:extLst xmlns:a="http://schemas.openxmlformats.org/drawingml/2006/main">
               <a:ext uri="{FF2B5EF4-FFF2-40B4-BE49-F238E27FC236}">
-                <a16:creationId xmlns:a16="http://schemas.microsoft.com/office/drawing/2014/main" id="{E5864BE5-0A08-4045-8D4E-1D3D0141DDC8}"/>
+                <a16:creationId xmlns:a16="http://schemas.microsoft.com/office/drawing/2014/main" id="{9B7A45EC-DA74-4DF8-8D3F-BB3C2E41D626}"/>
               </a:ext>
             </a:extLst>
           </p:cNvPr>
@@ -12461,7 +12461,7 @@
           <p:cNvPr id="10" name="">
             <a:extLst xmlns:a="http://schemas.openxmlformats.org/drawingml/2006/main">
               <a:ext uri="{FF2B5EF4-FFF2-40B4-BE49-F238E27FC236}">
-                <a16:creationId xmlns:a16="http://schemas.microsoft.com/office/drawing/2014/main" id="{BAC4E6F9-D223-4A04-AA76-0165D912A1E1}"/>
+                <a16:creationId xmlns:a16="http://schemas.microsoft.com/office/drawing/2014/main" id="{F81B675F-89C4-4FBB-B632-59AF03E5BD1B}"/>
               </a:ext>
             </a:extLst>
           </p:cNvPr>
@@ -12617,7 +12617,7 @@
           <p:cNvPr id="11" name="">
             <a:extLst xmlns:a="http://schemas.openxmlformats.org/drawingml/2006/main">
               <a:ext uri="{FF2B5EF4-FFF2-40B4-BE49-F238E27FC236}">
-                <a16:creationId xmlns:a16="http://schemas.microsoft.com/office/drawing/2014/main" id="{7E653F90-B79D-4E6E-95BD-9B3A8F798F84}"/>
+                <a16:creationId xmlns:a16="http://schemas.microsoft.com/office/drawing/2014/main" id="{6F79AC63-94B3-425E-93C5-C56FBCED5330}"/>
               </a:ext>
             </a:extLst>
           </p:cNvPr>
@@ -12771,7 +12771,7 @@
     </p:spTree>
     <p:extLst>
       <p:ext uri="{BB962C8B-B14F-4D97-AF65-F5344CB8AC3E}">
-        <p14:creationId xmlns:p14="http://schemas.microsoft.com/office/powerpoint/2010/main" val="1730687665"/>
+        <p14:creationId xmlns:p14="http://schemas.microsoft.com/office/powerpoint/2010/main" val="149607584"/>
       </p:ext>
     </p:extLst>
   </p:cSld>
@@ -12802,7 +12802,7 @@
           <p:cNvPr id="7" name="">
             <a:extLst xmlns:a="http://schemas.openxmlformats.org/drawingml/2006/main">
               <a:ext uri="{FF2B5EF4-FFF2-40B4-BE49-F238E27FC236}">
-                <a16:creationId xmlns:a16="http://schemas.microsoft.com/office/drawing/2014/main" id="{802DC098-7D92-4DFF-9AA0-4B48758EC84A}"/>
+                <a16:creationId xmlns:a16="http://schemas.microsoft.com/office/drawing/2014/main" id="{4E194CEE-7828-4E83-93AF-0E2A48587B79}"/>
               </a:ext>
             </a:extLst>
           </p:cNvPr>
@@ -12958,7 +12958,7 @@
           <p:cNvPr id="2" name="">
             <a:extLst xmlns:a="http://schemas.openxmlformats.org/drawingml/2006/main">
               <a:ext uri="{FF2B5EF4-FFF2-40B4-BE49-F238E27FC236}">
-                <a16:creationId xmlns:a16="http://schemas.microsoft.com/office/drawing/2014/main" id="{CF480B3F-695C-487A-A607-2EADB830153C}"/>
+                <a16:creationId xmlns:a16="http://schemas.microsoft.com/office/drawing/2014/main" id="{F0158401-9CC9-459E-971D-37E0F073A683}"/>
               </a:ext>
             </a:extLst>
           </p:cNvPr>
@@ -13114,7 +13114,7 @@
           <p:cNvPr id="3" name="">
             <a:extLst xmlns:a="http://schemas.openxmlformats.org/drawingml/2006/main">
               <a:ext uri="{FF2B5EF4-FFF2-40B4-BE49-F238E27FC236}">
-                <a16:creationId xmlns:a16="http://schemas.microsoft.com/office/drawing/2014/main" id="{A404C08F-3FED-4B9C-88C9-838AF13C8C97}"/>
+                <a16:creationId xmlns:a16="http://schemas.microsoft.com/office/drawing/2014/main" id="{B47E44C8-6161-4F53-B888-20B57AEE08DB}"/>
               </a:ext>
             </a:extLst>
           </p:cNvPr>
@@ -13270,7 +13270,7 @@
           <p:cNvPr id="4" name="">
             <a:extLst xmlns:a="http://schemas.openxmlformats.org/drawingml/2006/main">
               <a:ext uri="{FF2B5EF4-FFF2-40B4-BE49-F238E27FC236}">
-                <a16:creationId xmlns:a16="http://schemas.microsoft.com/office/drawing/2014/main" id="{B2FC2E78-7A2D-422E-B3B9-4177B28263FE}"/>
+                <a16:creationId xmlns:a16="http://schemas.microsoft.com/office/drawing/2014/main" id="{6D617BD3-74AD-46AD-BEF5-B0B9B6206BB5}"/>
               </a:ext>
             </a:extLst>
           </p:cNvPr>
@@ -13790,7 +13790,7 @@
           <p:cNvPr id="5" name="">
             <a:extLst xmlns:a="http://schemas.openxmlformats.org/drawingml/2006/main">
               <a:ext uri="{FF2B5EF4-FFF2-40B4-BE49-F238E27FC236}">
-                <a16:creationId xmlns:a16="http://schemas.microsoft.com/office/drawing/2014/main" id="{136A0691-C51F-4C73-BF87-2E17A9556E70}"/>
+                <a16:creationId xmlns:a16="http://schemas.microsoft.com/office/drawing/2014/main" id="{92246300-0BB8-4C3C-9E3C-C09A0AC4071B}"/>
               </a:ext>
             </a:extLst>
           </p:cNvPr>
@@ -13946,7 +13946,7 @@
           <p:cNvPr id="6" name="">
             <a:extLst xmlns:a="http://schemas.openxmlformats.org/drawingml/2006/main">
               <a:ext uri="{FF2B5EF4-FFF2-40B4-BE49-F238E27FC236}">
-                <a16:creationId xmlns:a16="http://schemas.microsoft.com/office/drawing/2014/main" id="{9A30F83B-CC58-40E8-9016-34AB9A31700F}"/>
+                <a16:creationId xmlns:a16="http://schemas.microsoft.com/office/drawing/2014/main" id="{1F448AE2-5EA2-49D7-9DA9-89B3ABD33ED6}"/>
               </a:ext>
             </a:extLst>
           </p:cNvPr>
@@ -14100,7 +14100,7 @@
     </p:spTree>
     <p:extLst>
       <p:ext uri="{BB962C8B-B14F-4D97-AF65-F5344CB8AC3E}">
-        <p14:creationId xmlns:p14="http://schemas.microsoft.com/office/powerpoint/2010/main" val="1929642193"/>
+        <p14:creationId xmlns:p14="http://schemas.microsoft.com/office/powerpoint/2010/main" val="1987561022"/>
       </p:ext>
     </p:extLst>
   </p:cSld>
@@ -14131,7 +14131,7 @@
           <p:cNvPr id="11" name="">
             <a:extLst xmlns:a="http://schemas.openxmlformats.org/drawingml/2006/main">
               <a:ext uri="{FF2B5EF4-FFF2-40B4-BE49-F238E27FC236}">
-                <a16:creationId xmlns:a16="http://schemas.microsoft.com/office/drawing/2014/main" id="{516D0142-B717-4D53-8A93-F0603D402FB1}"/>
+                <a16:creationId xmlns:a16="http://schemas.microsoft.com/office/drawing/2014/main" id="{4D7D1BF2-7827-4F14-993F-28EE3EB0C82A}"/>
               </a:ext>
             </a:extLst>
           </p:cNvPr>
@@ -14287,7 +14287,7 @@
           <p:cNvPr id="2" name="">
             <a:extLst xmlns:a="http://schemas.openxmlformats.org/drawingml/2006/main">
               <a:ext uri="{FF2B5EF4-FFF2-40B4-BE49-F238E27FC236}">
-                <a16:creationId xmlns:a16="http://schemas.microsoft.com/office/drawing/2014/main" id="{CA283C9B-4C05-46DA-A951-89D38A89B34E}"/>
+                <a16:creationId xmlns:a16="http://schemas.microsoft.com/office/drawing/2014/main" id="{1BB7786F-2A04-4347-B5DE-7EF1FF5A1AA6}"/>
               </a:ext>
             </a:extLst>
           </p:cNvPr>
@@ -14443,7 +14443,7 @@
           <p:cNvPr id="3" name="">
             <a:extLst xmlns:a="http://schemas.openxmlformats.org/drawingml/2006/main">
               <a:ext uri="{FF2B5EF4-FFF2-40B4-BE49-F238E27FC236}">
-                <a16:creationId xmlns:a16="http://schemas.microsoft.com/office/drawing/2014/main" id="{D85712DD-BD95-440C-85EF-72E8F2F0DBC8}"/>
+                <a16:creationId xmlns:a16="http://schemas.microsoft.com/office/drawing/2014/main" id="{ED281BF8-3329-42A5-8AA7-FEADD7A9F28F}"/>
               </a:ext>
             </a:extLst>
           </p:cNvPr>
@@ -14599,7 +14599,7 @@
           <p:cNvPr id="4" name="">
             <a:extLst xmlns:a="http://schemas.openxmlformats.org/drawingml/2006/main">
               <a:ext uri="{FF2B5EF4-FFF2-40B4-BE49-F238E27FC236}">
-                <a16:creationId xmlns:a16="http://schemas.microsoft.com/office/drawing/2014/main" id="{DD551630-8246-4F9B-B202-6699058DBA99}"/>
+                <a16:creationId xmlns:a16="http://schemas.microsoft.com/office/drawing/2014/main" id="{F0D4F884-892C-4488-936C-AB5EA283300A}"/>
               </a:ext>
             </a:extLst>
           </p:cNvPr>
@@ -14755,7 +14755,7 @@
           <p:cNvPr id="5" name="">
             <a:extLst xmlns:a="http://schemas.openxmlformats.org/drawingml/2006/main">
               <a:ext uri="{FF2B5EF4-FFF2-40B4-BE49-F238E27FC236}">
-                <a16:creationId xmlns:a16="http://schemas.microsoft.com/office/drawing/2014/main" id="{D88D8458-03A6-464C-9377-1A46B3542557}"/>
+                <a16:creationId xmlns:a16="http://schemas.microsoft.com/office/drawing/2014/main" id="{C461F478-55EC-4266-B252-E340DF4C8EB3}"/>
               </a:ext>
             </a:extLst>
           </p:cNvPr>
@@ -14911,7 +14911,7 @@
           <p:cNvPr id="6" name="">
             <a:extLst xmlns:a="http://schemas.openxmlformats.org/drawingml/2006/main">
               <a:ext uri="{FF2B5EF4-FFF2-40B4-BE49-F238E27FC236}">
-                <a16:creationId xmlns:a16="http://schemas.microsoft.com/office/drawing/2014/main" id="{0B98F1C0-A88D-4201-B31C-B1581E023656}"/>
+                <a16:creationId xmlns:a16="http://schemas.microsoft.com/office/drawing/2014/main" id="{E7FA0EF4-E045-4CF5-B31E-848EB8E7D4A5}"/>
               </a:ext>
             </a:extLst>
           </p:cNvPr>
@@ -14921,7 +14921,7 @@
           <p:nvPr/>
         </p:nvPicPr>
         <p:blipFill>
-          <a:blip xmlns:r="http://schemas.openxmlformats.org/officeDocument/2006/relationships" xmlns:a="http://schemas.openxmlformats.org/drawingml/2006/main" r:embed="Ra69f73e41bc14898"/>
+          <a:blip xmlns:r="http://schemas.openxmlformats.org/officeDocument/2006/relationships" xmlns:a="http://schemas.openxmlformats.org/drawingml/2006/main" r:embed="R9d744b74cd3c4378"/>
           <a:srcRect xmlns:a="http://schemas.openxmlformats.org/drawingml/2006/main" l="19000" t="78500" r="28000" b="4000"/>
           <a:stretch xmlns:a="http://schemas.openxmlformats.org/drawingml/2006/main"/>
         </p:blipFill>
@@ -14940,7 +14940,7 @@
           <p:cNvPr id="7" name="">
             <a:extLst xmlns:a="http://schemas.openxmlformats.org/drawingml/2006/main">
               <a:ext uri="{FF2B5EF4-FFF2-40B4-BE49-F238E27FC236}">
-                <a16:creationId xmlns:a16="http://schemas.microsoft.com/office/drawing/2014/main" id="{73534D95-8EC4-4FB6-A861-59C5691AF7B9}"/>
+                <a16:creationId xmlns:a16="http://schemas.microsoft.com/office/drawing/2014/main" id="{4390E5C0-C0C7-4996-A657-6A7BE30C0617}"/>
               </a:ext>
             </a:extLst>
           </p:cNvPr>
@@ -14950,7 +14950,7 @@
           <p:nvPr/>
         </p:nvPicPr>
         <p:blipFill>
-          <a:blip xmlns:r="http://schemas.openxmlformats.org/officeDocument/2006/relationships" xmlns:a="http://schemas.openxmlformats.org/drawingml/2006/main" r:embed="Rbd340570857d4e15"/>
+          <a:blip xmlns:r="http://schemas.openxmlformats.org/officeDocument/2006/relationships" xmlns:a="http://schemas.openxmlformats.org/drawingml/2006/main" r:embed="R3af8ed2110e04870"/>
           <a:srcRect xmlns:a="http://schemas.openxmlformats.org/drawingml/2006/main" l="19000" t="53000" r="28000" b="22000"/>
           <a:stretch xmlns:a="http://schemas.openxmlformats.org/drawingml/2006/main"/>
         </p:blipFill>
@@ -14969,7 +14969,7 @@
           <p:cNvPr id="8" name="">
             <a:extLst xmlns:a="http://schemas.openxmlformats.org/drawingml/2006/main">
               <a:ext uri="{FF2B5EF4-FFF2-40B4-BE49-F238E27FC236}">
-                <a16:creationId xmlns:a16="http://schemas.microsoft.com/office/drawing/2014/main" id="{DBB53474-7305-4B14-900D-B9EE0080991E}"/>
+                <a16:creationId xmlns:a16="http://schemas.microsoft.com/office/drawing/2014/main" id="{45A84703-2D50-4050-B313-5ECFDA417C93}"/>
               </a:ext>
             </a:extLst>
           </p:cNvPr>
@@ -15125,7 +15125,7 @@
           <p:cNvPr id="9" name="">
             <a:extLst xmlns:a="http://schemas.openxmlformats.org/drawingml/2006/main">
               <a:ext uri="{FF2B5EF4-FFF2-40B4-BE49-F238E27FC236}">
-                <a16:creationId xmlns:a16="http://schemas.microsoft.com/office/drawing/2014/main" id="{4B6D5AF9-FC0B-4EC1-9970-FC9C03F44718}"/>
+                <a16:creationId xmlns:a16="http://schemas.microsoft.com/office/drawing/2014/main" id="{D8B90442-FC45-4A25-A4AE-029EABC4EEE4}"/>
               </a:ext>
             </a:extLst>
           </p:cNvPr>
@@ -15281,7 +15281,7 @@
           <p:cNvPr id="10" name="">
             <a:extLst xmlns:a="http://schemas.openxmlformats.org/drawingml/2006/main">
               <a:ext uri="{FF2B5EF4-FFF2-40B4-BE49-F238E27FC236}">
-                <a16:creationId xmlns:a16="http://schemas.microsoft.com/office/drawing/2014/main" id="{DFA0EB1C-E67C-45F5-88DC-807EB947B31B}"/>
+                <a16:creationId xmlns:a16="http://schemas.microsoft.com/office/drawing/2014/main" id="{14E00D42-574D-4410-A638-64D0CC1D79A0}"/>
               </a:ext>
             </a:extLst>
           </p:cNvPr>
@@ -15435,7 +15435,7 @@
     </p:spTree>
     <p:extLst>
       <p:ext uri="{BB962C8B-B14F-4D97-AF65-F5344CB8AC3E}">
-        <p14:creationId xmlns:p14="http://schemas.microsoft.com/office/powerpoint/2010/main" val="1285740720"/>
+        <p14:creationId xmlns:p14="http://schemas.microsoft.com/office/powerpoint/2010/main" val="1992040975"/>
       </p:ext>
     </p:extLst>
   </p:cSld>
@@ -15466,7 +15466,7 @@
           <p:cNvPr id="9" name="">
             <a:extLst xmlns:a="http://schemas.openxmlformats.org/drawingml/2006/main">
               <a:ext uri="{FF2B5EF4-FFF2-40B4-BE49-F238E27FC236}">
-                <a16:creationId xmlns:a16="http://schemas.microsoft.com/office/drawing/2014/main" id="{6986377D-FC42-47A8-980A-060808ACDCA5}"/>
+                <a16:creationId xmlns:a16="http://schemas.microsoft.com/office/drawing/2014/main" id="{7A7E92E8-7BB0-4944-B46F-96B4C405B3F7}"/>
               </a:ext>
             </a:extLst>
           </p:cNvPr>
@@ -15622,7 +15622,7 @@
           <p:cNvPr id="2" name="">
             <a:extLst xmlns:a="http://schemas.openxmlformats.org/drawingml/2006/main">
               <a:ext uri="{FF2B5EF4-FFF2-40B4-BE49-F238E27FC236}">
-                <a16:creationId xmlns:a16="http://schemas.microsoft.com/office/drawing/2014/main" id="{F6E20632-8AFC-4BF8-89D6-33EE61961AEE}"/>
+                <a16:creationId xmlns:a16="http://schemas.microsoft.com/office/drawing/2014/main" id="{158EDE80-CD5E-40AD-8783-D3849647C469}"/>
               </a:ext>
             </a:extLst>
           </p:cNvPr>
@@ -15778,7 +15778,7 @@
           <p:cNvPr id="3" name="">
             <a:extLst xmlns:a="http://schemas.openxmlformats.org/drawingml/2006/main">
               <a:ext uri="{FF2B5EF4-FFF2-40B4-BE49-F238E27FC236}">
-                <a16:creationId xmlns:a16="http://schemas.microsoft.com/office/drawing/2014/main" id="{75A79C02-34D0-462F-A6A2-864DB41F5134}"/>
+                <a16:creationId xmlns:a16="http://schemas.microsoft.com/office/drawing/2014/main" id="{27842E44-7890-4FC9-B9EC-C59D8D996A7B}"/>
               </a:ext>
             </a:extLst>
           </p:cNvPr>
@@ -15934,7 +15934,7 @@
           <p:cNvPr id="4" name="">
             <a:extLst xmlns:a="http://schemas.openxmlformats.org/drawingml/2006/main">
               <a:ext uri="{FF2B5EF4-FFF2-40B4-BE49-F238E27FC236}">
-                <a16:creationId xmlns:a16="http://schemas.microsoft.com/office/drawing/2014/main" id="{171332FB-C5E1-4A88-B47F-A8B4B0812F4F}"/>
+                <a16:creationId xmlns:a16="http://schemas.microsoft.com/office/drawing/2014/main" id="{140E4C5A-AB1E-4E14-8962-FEB364BFFF61}"/>
               </a:ext>
             </a:extLst>
           </p:cNvPr>
@@ -16090,7 +16090,7 @@
           <p:cNvPr id="5" name="">
             <a:extLst xmlns:a="http://schemas.openxmlformats.org/drawingml/2006/main">
               <a:ext uri="{FF2B5EF4-FFF2-40B4-BE49-F238E27FC236}">
-                <a16:creationId xmlns:a16="http://schemas.microsoft.com/office/drawing/2014/main" id="{5DA46959-9693-40A0-A6C6-EA9EEEE0E050}"/>
+                <a16:creationId xmlns:a16="http://schemas.microsoft.com/office/drawing/2014/main" id="{9D333B85-788F-484B-803B-F2F29FBED81D}"/>
               </a:ext>
             </a:extLst>
           </p:cNvPr>
@@ -16715,7 +16715,7 @@
           <p:cNvPr id="6" name="">
             <a:extLst xmlns:a="http://schemas.openxmlformats.org/drawingml/2006/main">
               <a:ext uri="{FF2B5EF4-FFF2-40B4-BE49-F238E27FC236}">
-                <a16:creationId xmlns:a16="http://schemas.microsoft.com/office/drawing/2014/main" id="{EE4D6DF7-0A12-4B70-897D-FCD0C6004B6E}"/>
+                <a16:creationId xmlns:a16="http://schemas.microsoft.com/office/drawing/2014/main" id="{A97DC497-3F90-4FF8-8915-C3CBCC64DAEC}"/>
               </a:ext>
             </a:extLst>
           </p:cNvPr>
@@ -16871,7 +16871,7 @@
           <p:cNvPr id="7" name="">
             <a:extLst xmlns:a="http://schemas.openxmlformats.org/drawingml/2006/main">
               <a:ext uri="{FF2B5EF4-FFF2-40B4-BE49-F238E27FC236}">
-                <a16:creationId xmlns:a16="http://schemas.microsoft.com/office/drawing/2014/main" id="{09AF1863-3AA1-4DFB-8F7E-8EC8DE792E3B}"/>
+                <a16:creationId xmlns:a16="http://schemas.microsoft.com/office/drawing/2014/main" id="{A422D899-AB91-4F20-B39A-ED7A595CEFC2}"/>
               </a:ext>
             </a:extLst>
           </p:cNvPr>
@@ -17027,7 +17027,7 @@
           <p:cNvPr id="8" name="">
             <a:extLst xmlns:a="http://schemas.openxmlformats.org/drawingml/2006/main">
               <a:ext uri="{FF2B5EF4-FFF2-40B4-BE49-F238E27FC236}">
-                <a16:creationId xmlns:a16="http://schemas.microsoft.com/office/drawing/2014/main" id="{4DCDF32E-2285-4BD0-9E15-66C850348312}"/>
+                <a16:creationId xmlns:a16="http://schemas.microsoft.com/office/drawing/2014/main" id="{4BB7ECDD-279A-47F3-8527-82C437176EE9}"/>
               </a:ext>
             </a:extLst>
           </p:cNvPr>
@@ -17204,7 +17204,7 @@
     </p:spTree>
     <p:extLst>
       <p:ext uri="{BB962C8B-B14F-4D97-AF65-F5344CB8AC3E}">
-        <p14:creationId xmlns:p14="http://schemas.microsoft.com/office/powerpoint/2010/main" val="14315646"/>
+        <p14:creationId xmlns:p14="http://schemas.microsoft.com/office/powerpoint/2010/main" val="1201676430"/>
       </p:ext>
     </p:extLst>
   </p:cSld>
@@ -17235,7 +17235,7 @@
           <p:cNvPr id="9" name="">
             <a:extLst xmlns:a="http://schemas.openxmlformats.org/drawingml/2006/main">
               <a:ext uri="{FF2B5EF4-FFF2-40B4-BE49-F238E27FC236}">
-                <a16:creationId xmlns:a16="http://schemas.microsoft.com/office/drawing/2014/main" id="{3A2C356E-23B8-4B20-9035-8901525BACCB}"/>
+                <a16:creationId xmlns:a16="http://schemas.microsoft.com/office/drawing/2014/main" id="{CB313EDC-A4B4-4896-A9D9-27BC5880F3A4}"/>
               </a:ext>
             </a:extLst>
           </p:cNvPr>
@@ -17391,7 +17391,7 @@
           <p:cNvPr id="2" name="">
             <a:extLst xmlns:a="http://schemas.openxmlformats.org/drawingml/2006/main">
               <a:ext uri="{FF2B5EF4-FFF2-40B4-BE49-F238E27FC236}">
-                <a16:creationId xmlns:a16="http://schemas.microsoft.com/office/drawing/2014/main" id="{162C0CEB-7CCC-4009-86FF-53A29FB91726}"/>
+                <a16:creationId xmlns:a16="http://schemas.microsoft.com/office/drawing/2014/main" id="{20B187E6-968C-4FAF-9E11-340D99C1ECA6}"/>
               </a:ext>
             </a:extLst>
           </p:cNvPr>
@@ -17547,7 +17547,7 @@
           <p:cNvPr id="3" name="">
             <a:extLst xmlns:a="http://schemas.openxmlformats.org/drawingml/2006/main">
               <a:ext uri="{FF2B5EF4-FFF2-40B4-BE49-F238E27FC236}">
-                <a16:creationId xmlns:a16="http://schemas.microsoft.com/office/drawing/2014/main" id="{47E8098C-3ABA-4C6C-8EF3-89D85200078C}"/>
+                <a16:creationId xmlns:a16="http://schemas.microsoft.com/office/drawing/2014/main" id="{2C8BF553-6316-4AF8-AB6F-BB5005C01FBF}"/>
               </a:ext>
             </a:extLst>
           </p:cNvPr>
@@ -17703,7 +17703,7 @@
           <p:cNvPr id="4" name="">
             <a:extLst xmlns:a="http://schemas.openxmlformats.org/drawingml/2006/main">
               <a:ext uri="{FF2B5EF4-FFF2-40B4-BE49-F238E27FC236}">
-                <a16:creationId xmlns:a16="http://schemas.microsoft.com/office/drawing/2014/main" id="{8E5E3EAA-C0BD-4E6E-8AE7-901A537493B1}"/>
+                <a16:creationId xmlns:a16="http://schemas.microsoft.com/office/drawing/2014/main" id="{C3F4A604-E579-4E19-8CA3-BFABBB3F568E}"/>
               </a:ext>
             </a:extLst>
           </p:cNvPr>
@@ -17859,7 +17859,7 @@
           <p:cNvPr id="5" name="">
             <a:extLst xmlns:a="http://schemas.openxmlformats.org/drawingml/2006/main">
               <a:ext uri="{FF2B5EF4-FFF2-40B4-BE49-F238E27FC236}">
-                <a16:creationId xmlns:a16="http://schemas.microsoft.com/office/drawing/2014/main" id="{7F61E9FD-D2D8-4C11-A614-32DF8FBA068E}"/>
+                <a16:creationId xmlns:a16="http://schemas.microsoft.com/office/drawing/2014/main" id="{DFCBFC15-4ACA-49DD-8CD9-F84E82DEE474}"/>
               </a:ext>
             </a:extLst>
           </p:cNvPr>
@@ -18015,7 +18015,7 @@
           <p:cNvPr id="6" name="">
             <a:extLst xmlns:a="http://schemas.openxmlformats.org/drawingml/2006/main">
               <a:ext uri="{FF2B5EF4-FFF2-40B4-BE49-F238E27FC236}">
-                <a16:creationId xmlns:a16="http://schemas.microsoft.com/office/drawing/2014/main" id="{F97B431E-FF8E-4BD5-B4A8-3ABCEBB55436}"/>
+                <a16:creationId xmlns:a16="http://schemas.microsoft.com/office/drawing/2014/main" id="{F82C871D-94FB-449F-9B2E-D73576931A54}"/>
               </a:ext>
             </a:extLst>
           </p:cNvPr>
@@ -18171,7 +18171,7 @@
           <p:cNvPr id="7" name="">
             <a:extLst xmlns:a="http://schemas.openxmlformats.org/drawingml/2006/main">
               <a:ext uri="{FF2B5EF4-FFF2-40B4-BE49-F238E27FC236}">
-                <a16:creationId xmlns:a16="http://schemas.microsoft.com/office/drawing/2014/main" id="{E3E266DA-FE87-4821-8910-5BA279184278}"/>
+                <a16:creationId xmlns:a16="http://schemas.microsoft.com/office/drawing/2014/main" id="{73C605FD-3C50-43D7-A918-251150A1E616}"/>
               </a:ext>
             </a:extLst>
           </p:cNvPr>
@@ -18682,7 +18682,7 @@
           <p:cNvPr id="8" name="">
             <a:extLst xmlns:a="http://schemas.openxmlformats.org/drawingml/2006/main">
               <a:ext uri="{FF2B5EF4-FFF2-40B4-BE49-F238E27FC236}">
-                <a16:creationId xmlns:a16="http://schemas.microsoft.com/office/drawing/2014/main" id="{A7ED216A-EFC3-453A-9E4E-BEBC466007A8}"/>
+                <a16:creationId xmlns:a16="http://schemas.microsoft.com/office/drawing/2014/main" id="{E6605F2B-D5F3-44E1-ABA4-D55E91A5ACA0}"/>
               </a:ext>
             </a:extLst>
           </p:cNvPr>
@@ -18859,7 +18859,7 @@
     </p:spTree>
     <p:extLst>
       <p:ext uri="{BB962C8B-B14F-4D97-AF65-F5344CB8AC3E}">
-        <p14:creationId xmlns:p14="http://schemas.microsoft.com/office/powerpoint/2010/main" val="1134471967"/>
+        <p14:creationId xmlns:p14="http://schemas.microsoft.com/office/powerpoint/2010/main" val="361043273"/>
       </p:ext>
     </p:extLst>
   </p:cSld>

</xml_diff>